<commit_message>
feat: update demo presentation
</commit_message>
<xml_diff>
--- a/presentation/Capstone-Project.pptx
+++ b/presentation/Capstone-Project.pptx
@@ -5,10 +5,10 @@
     <p:sldMasterId id="2147483648" r:id="rId4"/>
   </p:sldMasterIdLst>
   <p:notesMasterIdLst>
-    <p:notesMasterId r:id="rId23"/>
+    <p:notesMasterId r:id="rId26"/>
   </p:notesMasterIdLst>
   <p:handoutMasterIdLst>
-    <p:handoutMasterId r:id="rId24"/>
+    <p:handoutMasterId r:id="rId27"/>
   </p:handoutMasterIdLst>
   <p:sldIdLst>
     <p:sldId id="292" r:id="rId5"/>
@@ -23,12 +23,15 @@
     <p:sldId id="308" r:id="rId14"/>
     <p:sldId id="309" r:id="rId15"/>
     <p:sldId id="310" r:id="rId16"/>
-    <p:sldId id="315" r:id="rId17"/>
-    <p:sldId id="317" r:id="rId18"/>
-    <p:sldId id="319" r:id="rId19"/>
-    <p:sldId id="318" r:id="rId20"/>
-    <p:sldId id="311" r:id="rId21"/>
-    <p:sldId id="289" r:id="rId22"/>
+    <p:sldId id="317" r:id="rId17"/>
+    <p:sldId id="320" r:id="rId18"/>
+    <p:sldId id="321" r:id="rId19"/>
+    <p:sldId id="319" r:id="rId20"/>
+    <p:sldId id="318" r:id="rId21"/>
+    <p:sldId id="315" r:id="rId22"/>
+    <p:sldId id="322" r:id="rId23"/>
+    <p:sldId id="311" r:id="rId24"/>
+    <p:sldId id="289" r:id="rId25"/>
   </p:sldIdLst>
   <p:sldSz cx="12192000" cy="6858000"/>
   <p:notesSz cx="6858000" cy="9144000"/>
@@ -249,7 +252,7 @@
           <a:p>
             <a:fld id="{8CD26A2A-0A96-0647-84E5-C82F2EFD9474}" type="datetimeFigureOut">
               <a:rPr lang="en-US" smtClean="0"/>
-              <a:t>9/3/2026</a:t>
+              <a:t>9/4/2026</a:t>
             </a:fld>
             <a:endParaRPr lang="en-US" dirty="0"/>
           </a:p>
@@ -514,7 +517,7 @@
           <a:p>
             <a:fld id="{5B0CF20C-6BCC-41A4-8C16-5A346425718D}" type="datetimeFigureOut">
               <a:rPr lang="en-US" smtClean="0"/>
-              <a:t>9/3/2026</a:t>
+              <a:t>9/4/2026</a:t>
             </a:fld>
             <a:endParaRPr lang="en-US" dirty="0"/>
           </a:p>
@@ -1058,7 +1061,7 @@
           <a:p>
             <a:fld id="{017105BD-6D6F-49DB-9DE4-D4A6452D7E5F}" type="slidenum">
               <a:rPr lang="en-US" altLang="zh-CN" noProof="0" smtClean="0"/>
-              <a:t>18</a:t>
+              <a:t>21</a:t>
             </a:fld>
             <a:endParaRPr lang="en-US" altLang="zh-CN" noProof="0" dirty="0"/>
           </a:p>
@@ -13323,7 +13326,7 @@
           <a:p>
             <a:r>
               <a:rPr lang="en-US" dirty="0"/>
-              <a:t>Eliminate wildcards from policies (target specific resources)</a:t>
+              <a:t>Implement Workload Optimization. </a:t>
             </a:r>
           </a:p>
           <a:p>
@@ -13335,7 +13338,7 @@
           <a:p>
             <a:r>
               <a:rPr lang="en-US" dirty="0"/>
-              <a:t>Remove unrestricted egress from security groups. </a:t>
+              <a:t>Further optimization of CI/CD Pipelines. Blue/Green development</a:t>
             </a:r>
           </a:p>
           <a:p>
@@ -13652,72 +13655,6 @@
         <p:cNvPr id="1" name="">
           <a:extLst>
             <a:ext uri="{FF2B5EF4-FFF2-40B4-BE49-F238E27FC236}">
-              <a16:creationId xmlns:a16="http://schemas.microsoft.com/office/drawing/2014/main" id="{78A99847-318E-595A-0434-1BFC2EC90F88}"/>
-            </a:ext>
-          </a:extLst>
-        </p:cNvPr>
-        <p:cNvGrpSpPr/>
-        <p:nvPr/>
-      </p:nvGrpSpPr>
-      <p:grpSpPr>
-        <a:xfrm>
-          <a:off x="0" y="0"/>
-          <a:ext cx="0" cy="0"/>
-          <a:chOff x="0" y="0"/>
-          <a:chExt cx="0" cy="0"/>
-        </a:xfrm>
-      </p:grpSpPr>
-      <p:pic>
-        <p:nvPicPr>
-          <p:cNvPr id="4" name="Picture 3">
-            <a:extLst>
-              <a:ext uri="{FF2B5EF4-FFF2-40B4-BE49-F238E27FC236}">
-                <a16:creationId xmlns:a16="http://schemas.microsoft.com/office/drawing/2014/main" id="{712C2E6C-7E9E-DBAE-2AB4-1A4C4E1F35CC}"/>
-              </a:ext>
-            </a:extLst>
-          </p:cNvPr>
-          <p:cNvPicPr>
-            <a:picLocks noChangeAspect="1"/>
-          </p:cNvPicPr>
-          <p:nvPr/>
-        </p:nvPicPr>
-        <p:blipFill>
-          <a:blip r:embed="rId2"/>
-          <a:stretch>
-            <a:fillRect/>
-          </a:stretch>
-        </p:blipFill>
-        <p:spPr>
-          <a:xfrm>
-            <a:off x="190272" y="610326"/>
-            <a:ext cx="11811455" cy="5455739"/>
-          </a:xfrm>
-          <a:prstGeom prst="rect">
-            <a:avLst/>
-          </a:prstGeom>
-        </p:spPr>
-      </p:pic>
-    </p:spTree>
-    <p:extLst>
-      <p:ext uri="{BB962C8B-B14F-4D97-AF65-F5344CB8AC3E}">
-        <p14:creationId xmlns:p14="http://schemas.microsoft.com/office/powerpoint/2010/main" val="2413797091"/>
-      </p:ext>
-    </p:extLst>
-  </p:cSld>
-  <p:clrMapOvr>
-    <a:masterClrMapping/>
-  </p:clrMapOvr>
-</p:sld>
-</file>
-
-<file path=ppt/slides/slide14.xml><?xml version="1.0" encoding="utf-8"?>
-<p:sld xmlns:a="http://schemas.openxmlformats.org/drawingml/2006/main" xmlns:r="http://schemas.openxmlformats.org/officeDocument/2006/relationships" xmlns:p="http://schemas.openxmlformats.org/presentationml/2006/main">
-  <p:cSld>
-    <p:spTree>
-      <p:nvGrpSpPr>
-        <p:cNvPr id="1" name="">
-          <a:extLst>
-            <a:ext uri="{FF2B5EF4-FFF2-40B4-BE49-F238E27FC236}">
               <a16:creationId xmlns:a16="http://schemas.microsoft.com/office/drawing/2014/main" id="{1A29C723-0C99-3302-82EA-1F7E3D6E3405}"/>
             </a:ext>
           </a:extLst>
@@ -13776,7 +13713,127 @@
 </p:sld>
 </file>
 
+<file path=ppt/slides/slide14.xml><?xml version="1.0" encoding="utf-8"?>
+<p:sld xmlns:a="http://schemas.openxmlformats.org/drawingml/2006/main" xmlns:r="http://schemas.openxmlformats.org/officeDocument/2006/relationships" xmlns:p="http://schemas.openxmlformats.org/presentationml/2006/main">
+  <p:cSld>
+    <p:spTree>
+      <p:nvGrpSpPr>
+        <p:cNvPr id="1" name=""/>
+        <p:cNvGrpSpPr/>
+        <p:nvPr/>
+      </p:nvGrpSpPr>
+      <p:grpSpPr>
+        <a:xfrm>
+          <a:off x="0" y="0"/>
+          <a:ext cx="0" cy="0"/>
+          <a:chOff x="0" y="0"/>
+          <a:chExt cx="0" cy="0"/>
+        </a:xfrm>
+      </p:grpSpPr>
+      <p:pic>
+        <p:nvPicPr>
+          <p:cNvPr id="5" name="Picture 4">
+            <a:extLst>
+              <a:ext uri="{FF2B5EF4-FFF2-40B4-BE49-F238E27FC236}">
+                <a16:creationId xmlns:a16="http://schemas.microsoft.com/office/drawing/2014/main" id="{2392DA60-CB65-784B-BC08-B3E65690AECE}"/>
+              </a:ext>
+            </a:extLst>
+          </p:cNvPr>
+          <p:cNvPicPr>
+            <a:picLocks noChangeAspect="1"/>
+          </p:cNvPicPr>
+          <p:nvPr/>
+        </p:nvPicPr>
+        <p:blipFill>
+          <a:blip r:embed="rId2"/>
+          <a:stretch>
+            <a:fillRect/>
+          </a:stretch>
+        </p:blipFill>
+        <p:spPr>
+          <a:xfrm>
+            <a:off x="1306286" y="111297"/>
+            <a:ext cx="9452982" cy="6485445"/>
+          </a:xfrm>
+          <a:prstGeom prst="rect">
+            <a:avLst/>
+          </a:prstGeom>
+        </p:spPr>
+      </p:pic>
+    </p:spTree>
+    <p:extLst>
+      <p:ext uri="{BB962C8B-B14F-4D97-AF65-F5344CB8AC3E}">
+        <p14:creationId xmlns:p14="http://schemas.microsoft.com/office/powerpoint/2010/main" val="2444544552"/>
+      </p:ext>
+    </p:extLst>
+  </p:cSld>
+  <p:clrMapOvr>
+    <a:masterClrMapping/>
+  </p:clrMapOvr>
+</p:sld>
+</file>
+
 <file path=ppt/slides/slide15.xml><?xml version="1.0" encoding="utf-8"?>
+<p:sld xmlns:a="http://schemas.openxmlformats.org/drawingml/2006/main" xmlns:r="http://schemas.openxmlformats.org/officeDocument/2006/relationships" xmlns:p="http://schemas.openxmlformats.org/presentationml/2006/main">
+  <p:cSld>
+    <p:spTree>
+      <p:nvGrpSpPr>
+        <p:cNvPr id="1" name=""/>
+        <p:cNvGrpSpPr/>
+        <p:nvPr/>
+      </p:nvGrpSpPr>
+      <p:grpSpPr>
+        <a:xfrm>
+          <a:off x="0" y="0"/>
+          <a:ext cx="0" cy="0"/>
+          <a:chOff x="0" y="0"/>
+          <a:chExt cx="0" cy="0"/>
+        </a:xfrm>
+      </p:grpSpPr>
+      <p:pic>
+        <p:nvPicPr>
+          <p:cNvPr id="5" name="Picture 4">
+            <a:extLst>
+              <a:ext uri="{FF2B5EF4-FFF2-40B4-BE49-F238E27FC236}">
+                <a16:creationId xmlns:a16="http://schemas.microsoft.com/office/drawing/2014/main" id="{62373463-21A8-283E-9E7D-B856C1B1CAFB}"/>
+              </a:ext>
+            </a:extLst>
+          </p:cNvPr>
+          <p:cNvPicPr>
+            <a:picLocks noChangeAspect="1"/>
+          </p:cNvPicPr>
+          <p:nvPr/>
+        </p:nvPicPr>
+        <p:blipFill>
+          <a:blip r:embed="rId2"/>
+          <a:stretch>
+            <a:fillRect/>
+          </a:stretch>
+        </p:blipFill>
+        <p:spPr>
+          <a:xfrm>
+            <a:off x="1245599" y="177506"/>
+            <a:ext cx="9700802" cy="6502988"/>
+          </a:xfrm>
+          <a:prstGeom prst="rect">
+            <a:avLst/>
+          </a:prstGeom>
+        </p:spPr>
+      </p:pic>
+    </p:spTree>
+    <p:extLst>
+      <p:ext uri="{BB962C8B-B14F-4D97-AF65-F5344CB8AC3E}">
+        <p14:creationId xmlns:p14="http://schemas.microsoft.com/office/powerpoint/2010/main" val="2127879521"/>
+      </p:ext>
+    </p:extLst>
+  </p:cSld>
+  <p:clrMapOvr>
+    <a:masterClrMapping/>
+  </p:clrMapOvr>
+</p:sld>
+</file>
+
+<file path=ppt/slides/slide16.xml><?xml version="1.0" encoding="utf-8"?>
 <p:sld xmlns:a="http://schemas.openxmlformats.org/drawingml/2006/main" xmlns:r="http://schemas.openxmlformats.org/officeDocument/2006/relationships" xmlns:p="http://schemas.openxmlformats.org/presentationml/2006/main">
   <p:cSld>
     <p:spTree>
@@ -13842,7 +13899,7 @@
 </p:sld>
 </file>
 
-<file path=ppt/slides/slide16.xml><?xml version="1.0" encoding="utf-8"?>
+<file path=ppt/slides/slide17.xml><?xml version="1.0" encoding="utf-8"?>
 <p:sld xmlns:a="http://schemas.openxmlformats.org/drawingml/2006/main" xmlns:r="http://schemas.openxmlformats.org/officeDocument/2006/relationships" xmlns:p="http://schemas.openxmlformats.org/presentationml/2006/main">
   <p:cSld>
     <p:spTree>
@@ -13908,7 +13965,7 @@
 </p:sld>
 </file>
 
-<file path=ppt/slides/slide17.xml><?xml version="1.0" encoding="utf-8"?>
+<file path=ppt/slides/slide18.xml><?xml version="1.0" encoding="utf-8"?>
 <p:sld xmlns:a="http://schemas.openxmlformats.org/drawingml/2006/main" xmlns:r="http://schemas.openxmlformats.org/officeDocument/2006/relationships" xmlns:p="http://schemas.openxmlformats.org/presentationml/2006/main">
   <p:cSld>
     <p:spTree>
@@ -13916,7 +13973,7 @@
         <p:cNvPr id="1" name="">
           <a:extLst>
             <a:ext uri="{FF2B5EF4-FFF2-40B4-BE49-F238E27FC236}">
-              <a16:creationId xmlns:a16="http://schemas.microsoft.com/office/drawing/2014/main" id="{3726655F-266F-392E-3132-1F6021FF9EDF}"/>
+              <a16:creationId xmlns:a16="http://schemas.microsoft.com/office/drawing/2014/main" id="{78A99847-318E-595A-0434-1BFC2EC90F88}"/>
             </a:ext>
           </a:extLst>
         </p:cNvPr>
@@ -13931,43 +13988,40 @@
           <a:chExt cx="0" cy="0"/>
         </a:xfrm>
       </p:grpSpPr>
-      <p:sp>
-        <p:nvSpPr>
-          <p:cNvPr id="2" name="Title 1">
+      <p:pic>
+        <p:nvPicPr>
+          <p:cNvPr id="4" name="Picture 3">
             <a:extLst>
               <a:ext uri="{FF2B5EF4-FFF2-40B4-BE49-F238E27FC236}">
-                <a16:creationId xmlns:a16="http://schemas.microsoft.com/office/drawing/2014/main" id="{2D1D7D0B-B013-B95B-C6DD-C9BCB763B4CE}"/>
+                <a16:creationId xmlns:a16="http://schemas.microsoft.com/office/drawing/2014/main" id="{712C2E6C-7E9E-DBAE-2AB4-1A4C4E1F35CC}"/>
               </a:ext>
             </a:extLst>
           </p:cNvPr>
-          <p:cNvSpPr>
-            <a:spLocks noGrp="1"/>
-          </p:cNvSpPr>
-          <p:nvPr>
-            <p:ph type="title"/>
-          </p:nvPr>
-        </p:nvSpPr>
+          <p:cNvPicPr>
+            <a:picLocks noChangeAspect="1"/>
+          </p:cNvPicPr>
+          <p:nvPr/>
+        </p:nvPicPr>
+        <p:blipFill>
+          <a:blip r:embed="rId2"/>
+          <a:stretch>
+            <a:fillRect/>
+          </a:stretch>
+        </p:blipFill>
         <p:spPr>
           <a:xfrm>
-            <a:off x="5307204" y="2041071"/>
-            <a:ext cx="1577591" cy="2775857"/>
+            <a:off x="190272" y="610326"/>
+            <a:ext cx="11811455" cy="5455739"/>
           </a:xfrm>
+          <a:prstGeom prst="rect">
+            <a:avLst/>
+          </a:prstGeom>
         </p:spPr>
-        <p:txBody>
-          <a:bodyPr/>
-          <a:lstStyle/>
-          <a:p>
-            <a:r>
-              <a:rPr lang="en-US" dirty="0"/>
-              <a:t>Q&amp;A</a:t>
-            </a:r>
-          </a:p>
-        </p:txBody>
-      </p:sp>
+      </p:pic>
     </p:spTree>
     <p:extLst>
       <p:ext uri="{BB962C8B-B14F-4D97-AF65-F5344CB8AC3E}">
-        <p14:creationId xmlns:p14="http://schemas.microsoft.com/office/powerpoint/2010/main" val="2865962368"/>
+        <p14:creationId xmlns:p14="http://schemas.microsoft.com/office/powerpoint/2010/main" val="2413797091"/>
       </p:ext>
     </p:extLst>
   </p:cSld>
@@ -13977,7 +14031,7 @@
 </p:sld>
 </file>
 
-<file path=ppt/slides/slide18.xml><?xml version="1.0" encoding="utf-8"?>
+<file path=ppt/slides/slide19.xml><?xml version="1.0" encoding="utf-8"?>
 <p:sld xmlns:a="http://schemas.openxmlformats.org/drawingml/2006/main" xmlns:r="http://schemas.openxmlformats.org/officeDocument/2006/relationships" xmlns:p="http://schemas.openxmlformats.org/presentationml/2006/main">
   <p:cSld>
     <p:spTree>
@@ -13994,79 +14048,40 @@
           <a:chExt cx="0" cy="0"/>
         </a:xfrm>
       </p:grpSpPr>
-      <p:sp>
-        <p:nvSpPr>
-          <p:cNvPr id="24" name="Title 23">
+      <p:pic>
+        <p:nvPicPr>
+          <p:cNvPr id="11" name="Picture 10">
             <a:extLst>
               <a:ext uri="{FF2B5EF4-FFF2-40B4-BE49-F238E27FC236}">
-                <a16:creationId xmlns:a16="http://schemas.microsoft.com/office/drawing/2014/main" id="{AD2C8D04-263D-9589-1CFF-A5968D7C33D7}"/>
+                <a16:creationId xmlns:a16="http://schemas.microsoft.com/office/drawing/2014/main" id="{46862EC7-992C-1E3C-B65D-4C8A535B7F70}"/>
               </a:ext>
             </a:extLst>
           </p:cNvPr>
-          <p:cNvSpPr>
-            <a:spLocks noGrp="1"/>
-          </p:cNvSpPr>
-          <p:nvPr>
-            <p:ph type="title"/>
-          </p:nvPr>
-        </p:nvSpPr>
+          <p:cNvPicPr>
+            <a:picLocks noChangeAspect="1"/>
+          </p:cNvPicPr>
+          <p:nvPr/>
+        </p:nvPicPr>
+        <p:blipFill>
+          <a:blip r:embed="rId2"/>
+          <a:stretch>
+            <a:fillRect/>
+          </a:stretch>
+        </p:blipFill>
         <p:spPr>
           <a:xfrm>
-            <a:off x="6035040" y="731520"/>
-            <a:ext cx="5394960" cy="2103120"/>
+            <a:off x="0" y="595738"/>
+            <a:ext cx="12192000" cy="5666523"/>
           </a:xfrm>
+          <a:prstGeom prst="rect">
+            <a:avLst/>
+          </a:prstGeom>
         </p:spPr>
-        <p:txBody>
-          <a:bodyPr/>
-          <a:lstStyle/>
-          <a:p>
-            <a:r>
-              <a:rPr lang="en-US" dirty="0"/>
-              <a:t>Thank you</a:t>
-            </a:r>
-          </a:p>
-        </p:txBody>
-      </p:sp>
-      <p:sp>
-        <p:nvSpPr>
-          <p:cNvPr id="25" name="Text Placeholder 24">
-            <a:extLst>
-              <a:ext uri="{FF2B5EF4-FFF2-40B4-BE49-F238E27FC236}">
-                <a16:creationId xmlns:a16="http://schemas.microsoft.com/office/drawing/2014/main" id="{B993E4D5-4AD0-4740-096D-6822944C8FF6}"/>
-              </a:ext>
-            </a:extLst>
-          </p:cNvPr>
-          <p:cNvSpPr>
-            <a:spLocks noGrp="1"/>
-          </p:cNvSpPr>
-          <p:nvPr>
-            <p:ph type="body" sz="quarter" idx="27"/>
-          </p:nvPr>
-        </p:nvSpPr>
-        <p:spPr>
-          <a:xfrm>
-            <a:off x="6035040" y="3108960"/>
-            <a:ext cx="5394960" cy="1879791"/>
-          </a:xfrm>
-        </p:spPr>
-        <p:txBody>
-          <a:bodyPr/>
-          <a:lstStyle/>
-          <a:p>
-            <a:r>
-              <a:rPr lang="en-US" dirty="0"/>
-              <a:t>Julio Cesar Aldana Almanza</a:t>
-            </a:r>
-          </a:p>
-          <a:p>
-            <a:endParaRPr lang="en-US" dirty="0"/>
-          </a:p>
-        </p:txBody>
-      </p:sp>
+      </p:pic>
     </p:spTree>
     <p:extLst>
       <p:ext uri="{BB962C8B-B14F-4D97-AF65-F5344CB8AC3E}">
-        <p14:creationId xmlns:p14="http://schemas.microsoft.com/office/powerpoint/2010/main" val="529279411"/>
+        <p14:creationId xmlns:p14="http://schemas.microsoft.com/office/powerpoint/2010/main" val="1183025917"/>
       </p:ext>
     </p:extLst>
   </p:cSld>
@@ -14219,6 +14234,174 @@
     <p:extLst>
       <p:ext uri="{BB962C8B-B14F-4D97-AF65-F5344CB8AC3E}">
         <p14:creationId xmlns:p14="http://schemas.microsoft.com/office/powerpoint/2010/main" val="1485080791"/>
+      </p:ext>
+    </p:extLst>
+  </p:cSld>
+  <p:clrMapOvr>
+    <a:masterClrMapping/>
+  </p:clrMapOvr>
+</p:sld>
+</file>
+
+<file path=ppt/slides/slide20.xml><?xml version="1.0" encoding="utf-8"?>
+<p:sld xmlns:a="http://schemas.openxmlformats.org/drawingml/2006/main" xmlns:r="http://schemas.openxmlformats.org/officeDocument/2006/relationships" xmlns:p="http://schemas.openxmlformats.org/presentationml/2006/main">
+  <p:cSld>
+    <p:spTree>
+      <p:nvGrpSpPr>
+        <p:cNvPr id="1" name="">
+          <a:extLst>
+            <a:ext uri="{FF2B5EF4-FFF2-40B4-BE49-F238E27FC236}">
+              <a16:creationId xmlns:a16="http://schemas.microsoft.com/office/drawing/2014/main" id="{3726655F-266F-392E-3132-1F6021FF9EDF}"/>
+            </a:ext>
+          </a:extLst>
+        </p:cNvPr>
+        <p:cNvGrpSpPr/>
+        <p:nvPr/>
+      </p:nvGrpSpPr>
+      <p:grpSpPr>
+        <a:xfrm>
+          <a:off x="0" y="0"/>
+          <a:ext cx="0" cy="0"/>
+          <a:chOff x="0" y="0"/>
+          <a:chExt cx="0" cy="0"/>
+        </a:xfrm>
+      </p:grpSpPr>
+      <p:sp>
+        <p:nvSpPr>
+          <p:cNvPr id="2" name="Title 1">
+            <a:extLst>
+              <a:ext uri="{FF2B5EF4-FFF2-40B4-BE49-F238E27FC236}">
+                <a16:creationId xmlns:a16="http://schemas.microsoft.com/office/drawing/2014/main" id="{2D1D7D0B-B013-B95B-C6DD-C9BCB763B4CE}"/>
+              </a:ext>
+            </a:extLst>
+          </p:cNvPr>
+          <p:cNvSpPr>
+            <a:spLocks noGrp="1"/>
+          </p:cNvSpPr>
+          <p:nvPr>
+            <p:ph type="title"/>
+          </p:nvPr>
+        </p:nvSpPr>
+        <p:spPr>
+          <a:xfrm>
+            <a:off x="5307204" y="2041071"/>
+            <a:ext cx="1577591" cy="2775857"/>
+          </a:xfrm>
+        </p:spPr>
+        <p:txBody>
+          <a:bodyPr/>
+          <a:lstStyle/>
+          <a:p>
+            <a:r>
+              <a:rPr lang="en-US" dirty="0"/>
+              <a:t>Q&amp;A</a:t>
+            </a:r>
+          </a:p>
+        </p:txBody>
+      </p:sp>
+    </p:spTree>
+    <p:extLst>
+      <p:ext uri="{BB962C8B-B14F-4D97-AF65-F5344CB8AC3E}">
+        <p14:creationId xmlns:p14="http://schemas.microsoft.com/office/powerpoint/2010/main" val="2865962368"/>
+      </p:ext>
+    </p:extLst>
+  </p:cSld>
+  <p:clrMapOvr>
+    <a:masterClrMapping/>
+  </p:clrMapOvr>
+</p:sld>
+</file>
+
+<file path=ppt/slides/slide21.xml><?xml version="1.0" encoding="utf-8"?>
+<p:sld xmlns:a="http://schemas.openxmlformats.org/drawingml/2006/main" xmlns:r="http://schemas.openxmlformats.org/officeDocument/2006/relationships" xmlns:p="http://schemas.openxmlformats.org/presentationml/2006/main">
+  <p:cSld>
+    <p:spTree>
+      <p:nvGrpSpPr>
+        <p:cNvPr id="1" name=""/>
+        <p:cNvGrpSpPr/>
+        <p:nvPr/>
+      </p:nvGrpSpPr>
+      <p:grpSpPr>
+        <a:xfrm>
+          <a:off x="0" y="0"/>
+          <a:ext cx="0" cy="0"/>
+          <a:chOff x="0" y="0"/>
+          <a:chExt cx="0" cy="0"/>
+        </a:xfrm>
+      </p:grpSpPr>
+      <p:sp>
+        <p:nvSpPr>
+          <p:cNvPr id="24" name="Title 23">
+            <a:extLst>
+              <a:ext uri="{FF2B5EF4-FFF2-40B4-BE49-F238E27FC236}">
+                <a16:creationId xmlns:a16="http://schemas.microsoft.com/office/drawing/2014/main" id="{AD2C8D04-263D-9589-1CFF-A5968D7C33D7}"/>
+              </a:ext>
+            </a:extLst>
+          </p:cNvPr>
+          <p:cNvSpPr>
+            <a:spLocks noGrp="1"/>
+          </p:cNvSpPr>
+          <p:nvPr>
+            <p:ph type="title"/>
+          </p:nvPr>
+        </p:nvSpPr>
+        <p:spPr>
+          <a:xfrm>
+            <a:off x="6035040" y="731520"/>
+            <a:ext cx="5394960" cy="2103120"/>
+          </a:xfrm>
+        </p:spPr>
+        <p:txBody>
+          <a:bodyPr/>
+          <a:lstStyle/>
+          <a:p>
+            <a:r>
+              <a:rPr lang="en-US" dirty="0"/>
+              <a:t>Thank you</a:t>
+            </a:r>
+          </a:p>
+        </p:txBody>
+      </p:sp>
+      <p:sp>
+        <p:nvSpPr>
+          <p:cNvPr id="25" name="Text Placeholder 24">
+            <a:extLst>
+              <a:ext uri="{FF2B5EF4-FFF2-40B4-BE49-F238E27FC236}">
+                <a16:creationId xmlns:a16="http://schemas.microsoft.com/office/drawing/2014/main" id="{B993E4D5-4AD0-4740-096D-6822944C8FF6}"/>
+              </a:ext>
+            </a:extLst>
+          </p:cNvPr>
+          <p:cNvSpPr>
+            <a:spLocks noGrp="1"/>
+          </p:cNvSpPr>
+          <p:nvPr>
+            <p:ph type="body" sz="quarter" idx="27"/>
+          </p:nvPr>
+        </p:nvSpPr>
+        <p:spPr>
+          <a:xfrm>
+            <a:off x="6035040" y="3108960"/>
+            <a:ext cx="5394960" cy="1879791"/>
+          </a:xfrm>
+        </p:spPr>
+        <p:txBody>
+          <a:bodyPr/>
+          <a:lstStyle/>
+          <a:p>
+            <a:r>
+              <a:rPr lang="en-US" dirty="0"/>
+              <a:t>Julio Cesar Aldana Almanza</a:t>
+            </a:r>
+          </a:p>
+          <a:p>
+            <a:endParaRPr lang="en-US" dirty="0"/>
+          </a:p>
+        </p:txBody>
+      </p:sp>
+    </p:spTree>
+    <p:extLst>
+      <p:ext uri="{BB962C8B-B14F-4D97-AF65-F5344CB8AC3E}">
+        <p14:creationId xmlns:p14="http://schemas.microsoft.com/office/powerpoint/2010/main" val="529279411"/>
       </p:ext>
     </p:extLst>
   </p:cSld>
@@ -14547,19 +14730,19 @@
           <a:p>
             <a:r>
               <a:rPr lang="en-US" dirty="0"/>
-              <a:t>Presentation Subnets (Public</a:t>
+              <a:t>Presentation Subnets (Public)</a:t>
             </a:r>
           </a:p>
           <a:p>
             <a:r>
               <a:rPr lang="en-US" dirty="0"/>
-              <a:t>Application Subnets (Private):</a:t>
+              <a:t>Application Subnets (Private)</a:t>
             </a:r>
           </a:p>
           <a:p>
             <a:r>
               <a:rPr lang="en-US" dirty="0"/>
-              <a:t>Data Subnets (Private): </a:t>
+              <a:t>Data Subnets (Private) </a:t>
             </a:r>
           </a:p>
           <a:p>
@@ -14765,7 +14948,7 @@
             <a:pPr lvl="1"/>
             <a:r>
               <a:rPr lang="en-US" dirty="0"/>
-              <a:t>CPU Usage (Threshold &gt; 80%)</a:t>
+              <a:t>CPU Usage (Threshold &gt; 70%)</a:t>
             </a:r>
           </a:p>
           <a:p>
@@ -14779,7 +14962,7 @@
             <a:pPr lvl="1"/>
             <a:r>
               <a:rPr lang="en-US" dirty="0"/>
-              <a:t>Application Load Balancer Response Time</a:t>
+              <a:t>Unhealthy targets</a:t>
             </a:r>
           </a:p>
           <a:p>
@@ -16512,6 +16695,26 @@
 </file>
 
 <file path=customXml/item2.xml><?xml version="1.0" encoding="utf-8"?>
+<p:properties xmlns:p="http://schemas.microsoft.com/office/2006/metadata/properties" xmlns:xsi="http://www.w3.org/2001/XMLSchema-instance" xmlns:pc="http://schemas.microsoft.com/office/infopath/2007/PartnerControls">
+  <documentManagement>
+    <_ip_UnifiedCompliancePolicyUIAction xmlns="http://schemas.microsoft.com/sharepoint/v3" xsi:nil="true"/>
+    <Image xmlns="71af3243-3dd4-4a8d-8c0d-dd76da1f02a5">
+      <Url xsi:nil="true"/>
+      <Description xsi:nil="true"/>
+    </Image>
+    <Status xmlns="71af3243-3dd4-4a8d-8c0d-dd76da1f02a5">Not started</Status>
+    <Background xmlns="71af3243-3dd4-4a8d-8c0d-dd76da1f02a5">false</Background>
+    <_ip_UnifiedCompliancePolicyProperties xmlns="http://schemas.microsoft.com/sharepoint/v3" xsi:nil="true"/>
+    <ImageTagsTaxHTField xmlns="71af3243-3dd4-4a8d-8c0d-dd76da1f02a5">
+      <Terms xmlns="http://schemas.microsoft.com/office/infopath/2007/PartnerControls"/>
+    </ImageTagsTaxHTField>
+    <TaxCatchAll xmlns="230e9df3-be65-4c73-a93b-d1236ebd677e" xsi:nil="true"/>
+    <MediaServiceKeyPoints xmlns="71af3243-3dd4-4a8d-8c0d-dd76da1f02a5" xsi:nil="true"/>
+  </documentManagement>
+</p:properties>
+</file>
+
+<file path=customXml/item3.xml><?xml version="1.0" encoding="utf-8"?>
 <ct:contentTypeSchema xmlns:ct="http://schemas.microsoft.com/office/2006/metadata/contentType" xmlns:ma="http://schemas.microsoft.com/office/2006/metadata/properties/metaAttributes" ct:_="" ma:_="" ma:contentTypeName="Document" ma:contentTypeID="0x01010079F111ED35F8CC479449609E8A0923A6" ma:contentTypeVersion="30" ma:contentTypeDescription="Create a new document." ma:contentTypeScope="" ma:versionID="cec0622158e8f13124e9e8fd4de31bd1">
   <xsd:schema xmlns:xsd="http://www.w3.org/2001/XMLSchema" xmlns:xs="http://www.w3.org/2001/XMLSchema" xmlns:p="http://schemas.microsoft.com/office/2006/metadata/properties" xmlns:ns1="http://schemas.microsoft.com/sharepoint/v3" xmlns:ns2="71af3243-3dd4-4a8d-8c0d-dd76da1f02a5" xmlns:ns3="16c05727-aa75-4e4a-9b5f-8a80a1165891" xmlns:ns4="230e9df3-be65-4c73-a93b-d1236ebd677e" targetNamespace="http://schemas.microsoft.com/office/2006/metadata/properties" ma:root="true" ma:fieldsID="3b52f30ab005d15df08657af532e6e38" ns1:_="" ns2:_="" ns3:_="" ns4:_="">
     <xsd:import namespace="http://schemas.microsoft.com/sharepoint/v3"/>
@@ -16829,26 +17032,6 @@
 </ct:contentTypeSchema>
 </file>
 
-<file path=customXml/item3.xml><?xml version="1.0" encoding="utf-8"?>
-<p:properties xmlns:p="http://schemas.microsoft.com/office/2006/metadata/properties" xmlns:xsi="http://www.w3.org/2001/XMLSchema-instance" xmlns:pc="http://schemas.microsoft.com/office/infopath/2007/PartnerControls">
-  <documentManagement>
-    <_ip_UnifiedCompliancePolicyUIAction xmlns="http://schemas.microsoft.com/sharepoint/v3" xsi:nil="true"/>
-    <Image xmlns="71af3243-3dd4-4a8d-8c0d-dd76da1f02a5">
-      <Url xsi:nil="true"/>
-      <Description xsi:nil="true"/>
-    </Image>
-    <Status xmlns="71af3243-3dd4-4a8d-8c0d-dd76da1f02a5">Not started</Status>
-    <Background xmlns="71af3243-3dd4-4a8d-8c0d-dd76da1f02a5">false</Background>
-    <_ip_UnifiedCompliancePolicyProperties xmlns="http://schemas.microsoft.com/sharepoint/v3" xsi:nil="true"/>
-    <ImageTagsTaxHTField xmlns="71af3243-3dd4-4a8d-8c0d-dd76da1f02a5">
-      <Terms xmlns="http://schemas.microsoft.com/office/infopath/2007/PartnerControls"/>
-    </ImageTagsTaxHTField>
-    <TaxCatchAll xmlns="230e9df3-be65-4c73-a93b-d1236ebd677e" xsi:nil="true"/>
-    <MediaServiceKeyPoints xmlns="71af3243-3dd4-4a8d-8c0d-dd76da1f02a5" xsi:nil="true"/>
-  </documentManagement>
-</p:properties>
-</file>
-
 <file path=customXml/itemProps1.xml><?xml version="1.0" encoding="utf-8"?>
 <ds:datastoreItem xmlns:ds="http://schemas.openxmlformats.org/officeDocument/2006/customXml" ds:itemID="{B0009351-EDD4-484E-ACD6-D50CCB137637}">
   <ds:schemaRefs>
@@ -16858,6 +17041,18 @@
 </file>
 
 <file path=customXml/itemProps2.xml><?xml version="1.0" encoding="utf-8"?>
+<ds:datastoreItem xmlns:ds="http://schemas.openxmlformats.org/officeDocument/2006/customXml" ds:itemID="{C8DB3C62-858A-4A01-AFEF-21E0BB8CE262}">
+  <ds:schemaRefs>
+    <ds:schemaRef ds:uri="http://schemas.microsoft.com/office/2006/metadata/properties"/>
+    <ds:schemaRef ds:uri="http://schemas.microsoft.com/office/infopath/2007/PartnerControls"/>
+    <ds:schemaRef ds:uri="http://schemas.microsoft.com/sharepoint/v3"/>
+    <ds:schemaRef ds:uri="71af3243-3dd4-4a8d-8c0d-dd76da1f02a5"/>
+    <ds:schemaRef ds:uri="230e9df3-be65-4c73-a93b-d1236ebd677e"/>
+  </ds:schemaRefs>
+</ds:datastoreItem>
+</file>
+
+<file path=customXml/itemProps3.xml><?xml version="1.0" encoding="utf-8"?>
 <ds:datastoreItem xmlns:ds="http://schemas.openxmlformats.org/officeDocument/2006/customXml" ds:itemID="{79897CAE-455D-42C9-A951-0C21BC122543}">
   <ds:schemaRefs>
     <ds:schemaRef ds:uri="http://schemas.microsoft.com/office/2006/metadata/contentType"/>
@@ -16878,18 +17073,6 @@
 </ds:datastoreItem>
 </file>
 
-<file path=customXml/itemProps3.xml><?xml version="1.0" encoding="utf-8"?>
-<ds:datastoreItem xmlns:ds="http://schemas.openxmlformats.org/officeDocument/2006/customXml" ds:itemID="{C8DB3C62-858A-4A01-AFEF-21E0BB8CE262}">
-  <ds:schemaRefs>
-    <ds:schemaRef ds:uri="http://schemas.microsoft.com/office/2006/metadata/properties"/>
-    <ds:schemaRef ds:uri="http://schemas.microsoft.com/office/infopath/2007/PartnerControls"/>
-    <ds:schemaRef ds:uri="http://schemas.microsoft.com/sharepoint/v3"/>
-    <ds:schemaRef ds:uri="71af3243-3dd4-4a8d-8c0d-dd76da1f02a5"/>
-    <ds:schemaRef ds:uri="230e9df3-be65-4c73-a93b-d1236ebd677e"/>
-  </ds:schemaRefs>
-</ds:datastoreItem>
-</file>
-
 <file path=docMetadata/LabelInfo.xml><?xml version="1.0" encoding="utf-8"?>
 <clbl:labelList xmlns:clbl="http://schemas.microsoft.com/office/2020/mipLabelMetadata"/>
 </file>
</xml_diff>